<commit_message>
fix(document-skills): repair bounded PPTX create scaffold
Co-Authored-By: Claude Opus 5 (1M context) <noreply@anthropic.com>
</commit_message>
<xml_diff>
--- a/plugin/tests/fixtures/html-native.expected.pptx
+++ b/plugin/tests/fixtures/html-native.expected.pptx
@@ -14,27 +14,52 @@
 </file>
 
 <file path=ppt/slideLayouts/slideLayout1.xml><?xml version="1.0" encoding="utf-8"?>
-<p:sldLayout xmlns:p="http://schemas.openxmlformats.org/presentationml/2006/main">
+<p:sldLayout xmlns:a="http://schemas.openxmlformats.org/drawingml/2006/main" xmlns:p="http://schemas.openxmlformats.org/presentationml/2006/main">
   <p:cSld name="Title Slide">
     <p:spTree>
-      <p:nvGrpSpPr/>
-      <p:grpSpPr/>
+      <p:nvGrpSpPr>
+        <p:cNvPr id="1" name=""/>
+        <p:cNvGrpSpPr/>
+        <p:nvPr/>
+      </p:nvGrpSpPr>
+      <p:grpSpPr>
+        <a:xfrm>
+          <a:off x="0" y="0"/>
+          <a:ext cx="12192000" cy="6858000"/>
+          <a:chOff x="0" y="0"/>
+          <a:chExt cx="12192000" cy="6858000"/>
+        </a:xfrm>
+      </p:grpSpPr>
     </p:spTree>
   </p:cSld>
+  <p:clrMapOvr>
+    <a:masterClrMapping/>
+  </p:clrMapOvr>
 </p:sldLayout>
 </file>
 
 <file path=ppt/slideMasters/slideMaster1.xml><?xml version="1.0" encoding="utf-8"?>
-<p:sldMaster xmlns:p="http://schemas.openxmlformats.org/presentationml/2006/main" xmlns:r14="http://schemas.openxmlformats.org/officeDocument/2006/relationships">
+<p:sldMaster xmlns:a="http://schemas.openxmlformats.org/drawingml/2006/main" xmlns:p="http://schemas.openxmlformats.org/presentationml/2006/main" xmlns:r14="http://schemas.openxmlformats.org/officeDocument/2006/relationships">
   <p:cSld>
     <p:spTree>
-      <p:nvGrpSpPr/>
-      <p:grpSpPr/>
+      <p:nvGrpSpPr>
+        <p:cNvPr id="1" name=""/>
+        <p:cNvGrpSpPr/>
+        <p:nvPr/>
+      </p:nvGrpSpPr>
+      <p:grpSpPr>
+        <a:xfrm>
+          <a:off x="0" y="0"/>
+          <a:ext cx="12192000" cy="6858000"/>
+          <a:chOff x="0" y="0"/>
+          <a:chExt cx="12192000" cy="6858000"/>
+        </a:xfrm>
+      </p:grpSpPr>
     </p:spTree>
   </p:cSld>
-  <p:clrMap/>
+  <p:clrMap bg1="lt1" tx1="dk1" bg2="lt2" tx2="dk2" accent1="accent1" accent2="accent2" accent3="accent3" accent4="accent4" accent5="accent5" accent6="accent6" hlink="hlink" folHlink="folHlink"/>
   <p:sldLayoutIdLst>
-    <p:sldLayoutId id="2147483650" r14:id="rIdLayout1"/>
+    <p:sldLayoutId id="2147483649" r14:id="rIdLayout1"/>
   </p:sldLayoutIdLst>
   <p:txStyles/>
 </p:sldMaster>
@@ -209,7 +234,9 @@
       </p:pic>
     </p:spTree>
   </p:cSld>
-  <p:clrMapOvr/>
+  <p:clrMapOvr>
+    <a:masterClrMapping/>
+  </p:clrMapOvr>
 </p:sld>
 </file>
 
@@ -322,12 +349,122 @@
       </p:sp>
     </p:spTree>
   </p:cSld>
-  <p:clrMapOvr/>
+  <p:clrMapOvr>
+    <a:masterClrMapping/>
+  </p:clrMapOvr>
 </p:sld>
 </file>
 
 <file path=ppt/theme/theme1.xml><?xml version="1.0" encoding="utf-8"?>
 <a:theme xmlns:a="http://schemas.openxmlformats.org/drawingml/2006/main" name="Office Theme">
-  <a:themeElements/>
+  <a:themeElements>
+    <a:clrScheme name="Office">
+      <a:dk1>
+        <a:sysClr val="windowText" lastClr="000000"/>
+      </a:dk1>
+      <a:lt1>
+        <a:sysClr val="window" lastClr="FFFFFF"/>
+      </a:lt1>
+      <a:dk2>
+        <a:srgbClr val="44546A"/>
+      </a:dk2>
+      <a:lt2>
+        <a:srgbClr val="E7E6E6"/>
+      </a:lt2>
+      <a:accent1>
+        <a:srgbClr val="4472C4"/>
+      </a:accent1>
+      <a:accent2>
+        <a:srgbClr val="ED7D31"/>
+      </a:accent2>
+      <a:accent3>
+        <a:srgbClr val="A5A5A5"/>
+      </a:accent3>
+      <a:accent4>
+        <a:srgbClr val="FFC000"/>
+      </a:accent4>
+      <a:accent5>
+        <a:srgbClr val="5B9BD5"/>
+      </a:accent5>
+      <a:accent6>
+        <a:srgbClr val="70AD47"/>
+      </a:accent6>
+      <a:hlink>
+        <a:srgbClr val="0563C1"/>
+      </a:hlink>
+      <a:folHlink>
+        <a:srgbClr val="954F72"/>
+      </a:folHlink>
+    </a:clrScheme>
+    <a:fontScheme name="Office">
+      <a:majorFont>
+        <a:latin typeface="Calibri Light"/>
+        <a:ea typeface=""/>
+        <a:cs typeface=""/>
+      </a:majorFont>
+      <a:minorFont>
+        <a:latin typeface="Calibri"/>
+        <a:ea typeface=""/>
+        <a:cs typeface=""/>
+      </a:minorFont>
+    </a:fontScheme>
+    <a:fmtScheme>
+      <a:fillStyleLst>
+        <a:solidFill>
+          <a:schemeClr val="phClr"/>
+        </a:solidFill>
+        <a:gradFill>
+          <a:gsLst/>
+          <a:lin ang="0" scaled="0"/>
+        </a:gradFill>
+        <a:gradFill>
+          <a:gsLst/>
+          <a:lin ang="0" scaled="0"/>
+        </a:gradFill>
+      </a:fillStyleLst>
+      <a:lnStyleLst>
+        <a:ln w="9100" cap="flat" cmpd="sng" algn="ctr">
+          <a:solidFill>
+            <a:schemeClr val="phClr"/>
+          </a:solidFill>
+          <a:prstDash val="solid"/>
+        </a:ln>
+        <a:ln w="9100" cap="flat" cmpd="sng" algn="ctr">
+          <a:solidFill>
+            <a:schemeClr val="phClr"/>
+          </a:solidFill>
+          <a:prstDash val="solid"/>
+        </a:ln>
+        <a:ln w="9100" cap="flat" cmpd="sng" algn="ctr">
+          <a:solidFill>
+            <a:schemeClr val="phClr"/>
+          </a:solidFill>
+          <a:prstDash val="solid"/>
+        </a:ln>
+      </a:lnStyleLst>
+      <a:effectStyleLst>
+        <a:effectStyle>
+          <a:effectLst/>
+        </a:effectStyle>
+        <a:effectStyle>
+          <a:effectLst/>
+        </a:effectStyle>
+        <a:effectStyle>
+          <a:effectLst/>
+        </a:effectStyle>
+      </a:effectStyleLst>
+      <a:bgFillStyleLst>
+        <a:solidFill>
+          <a:schemeClr val="phClr"/>
+        </a:solidFill>
+        <a:solidFill>
+          <a:schemeClr val="phClr"/>
+        </a:solidFill>
+        <a:solidFill>
+          <a:schemeClr val="phClr"/>
+        </a:solidFill>
+      </a:bgFillStyleLst>
+    </a:fmtScheme>
+  </a:themeElements>
 </a:theme>
 </file>
</xml_diff>

<commit_message>
feat(pptx): strengthen html fidelity and resource evidence
</commit_message>
<xml_diff>
--- a/plugin/tests/fixtures/html-native.expected.pptx
+++ b/plugin/tests/fixtures/html-native.expected.pptx
@@ -15,7 +15,7 @@
 
 <file path=ppt/slideLayouts/slideLayout1.xml><?xml version="1.0" encoding="utf-8"?>
 <p:sldLayout xmlns:a="http://schemas.openxmlformats.org/drawingml/2006/main" xmlns:p="http://schemas.openxmlformats.org/presentationml/2006/main">
-  <p:cSld name="Title Slide">
+  <p:cSld name="Cover">
     <p:spTree>
       <p:nvGrpSpPr>
         <p:cNvPr id="1" name=""/>
@@ -41,6 +41,14 @@
 <file path=ppt/slideMasters/slideMaster1.xml><?xml version="1.0" encoding="utf-8"?>
 <p:sldMaster xmlns:a="http://schemas.openxmlformats.org/drawingml/2006/main" xmlns:p="http://schemas.openxmlformats.org/presentationml/2006/main" xmlns:r14="http://schemas.openxmlformats.org/officeDocument/2006/relationships">
   <p:cSld>
+    <p:bg>
+      <p:bgPr>
+        <a:solidFill>
+          <a:srgbClr val="FFFFFF"/>
+        </a:solidFill>
+        <a:effectLst/>
+      </p:bgPr>
+    </p:bg>
     <p:spTree>
       <p:nvGrpSpPr>
         <p:cNvPr id="1" name=""/>
@@ -61,7 +69,38 @@
   <p:sldLayoutIdLst>
     <p:sldLayoutId id="2147483649" r14:id="rIdLayout1"/>
   </p:sldLayoutIdLst>
-  <p:txStyles/>
+  <p:txStyles>
+    <p:titleStyle>
+      <a:lvl1pPr>
+        <a:defRPr sz="3000" b="1">
+          <a:solidFill>
+            <a:srgbClr val="000000"/>
+          </a:solidFill>
+          <a:latin typeface="+mj-lt"/>
+        </a:defRPr>
+      </a:lvl1pPr>
+    </p:titleStyle>
+    <p:bodyStyle>
+      <a:lvl1pPr>
+        <a:defRPr sz="1800">
+          <a:solidFill>
+            <a:srgbClr val="222222"/>
+          </a:solidFill>
+          <a:latin typeface="+mn-lt"/>
+        </a:defRPr>
+      </a:lvl1pPr>
+    </p:bodyStyle>
+    <p:otherStyle>
+      <a:lvl1pPr>
+        <a:defRPr sz="1800">
+          <a:solidFill>
+            <a:srgbClr val="222222"/>
+          </a:solidFill>
+          <a:latin typeface="+mn-lt"/>
+        </a:defRPr>
+      </a:lvl1pPr>
+    </p:otherStyle>
+  </p:txStyles>
 </p:sldMaster>
 </file>
 
@@ -356,9 +395,9 @@
 </file>
 
 <file path=ppt/theme/theme1.xml><?xml version="1.0" encoding="utf-8"?>
-<a:theme xmlns:a="http://schemas.openxmlformats.org/drawingml/2006/main" name="Office Theme">
+<a:theme xmlns:a="http://schemas.openxmlformats.org/drawingml/2006/main" name="Elftia Office">
   <a:themeElements>
-    <a:clrScheme name="Office">
+    <a:clrScheme name="Elftia Office">
       <a:dk1>
         <a:sysClr val="windowText" lastClr="000000"/>
       </a:dk1>
@@ -396,7 +435,7 @@
         <a:srgbClr val="954F72"/>
       </a:folHlink>
     </a:clrScheme>
-    <a:fontScheme name="Office">
+    <a:fontScheme name="Elftia Office">
       <a:majorFont>
         <a:latin typeface="Calibri Light"/>
         <a:ea typeface=""/>

</xml_diff>

<commit_message>
fix(document-skills): close final xlsx integration gaps
</commit_message>
<xml_diff>
--- a/plugin/tests/fixtures/html-native.expected.pptx
+++ b/plugin/tests/fixtures/html-native.expected.pptx
@@ -124,8 +124,8 @@
       <p:grpSpPr>
         <a:xfrm>
           <a:off x="0" y="0"/>
+          <a:ext cx="12192000" cy="6858000"/>
           <a:chOff x="0" y="0"/>
-          <a:ext cx="12192000" cy="6858000"/>
           <a:chExt cx="12192000" cy="6858000"/>
         </a:xfrm>
       </p:grpSpPr>
@@ -299,8 +299,8 @@
       <p:grpSpPr>
         <a:xfrm>
           <a:off x="0" y="0"/>
+          <a:ext cx="12192000" cy="6858000"/>
           <a:chOff x="0" y="0"/>
-          <a:ext cx="12192000" cy="6858000"/>
           <a:chExt cx="12192000" cy="6858000"/>
         </a:xfrm>
       </p:grpSpPr>
@@ -453,11 +453,25 @@
           <a:schemeClr val="phClr"/>
         </a:solidFill>
         <a:gradFill>
-          <a:gsLst/>
+          <a:gsLst>
+            <a:gs pos="0">
+              <a:schemeClr val="phClr"/>
+            </a:gs>
+            <a:gs pos="100000">
+              <a:schemeClr val="phClr"/>
+            </a:gs>
+          </a:gsLst>
           <a:lin ang="0" scaled="0"/>
         </a:gradFill>
         <a:gradFill>
-          <a:gsLst/>
+          <a:gsLst>
+            <a:gs pos="0">
+              <a:schemeClr val="phClr"/>
+            </a:gs>
+            <a:gs pos="100000">
+              <a:schemeClr val="phClr"/>
+            </a:gs>
+          </a:gsLst>
           <a:lin ang="0" scaled="0"/>
         </a:gradFill>
       </a:fillStyleLst>

</xml_diff>

<commit_message>
fix(pptx): emit schema-valid OpenXML
</commit_message>
<xml_diff>
--- a/plugin/tests/fixtures/html-native.expected.pptx
+++ b/plugin/tests/fixtures/html-native.expected.pptx
@@ -124,8 +124,8 @@
       <p:grpSpPr>
         <a:xfrm>
           <a:off x="0" y="0"/>
+          <a:ext cx="12192000" cy="6858000"/>
           <a:chOff x="0" y="0"/>
-          <a:ext cx="12192000" cy="6858000"/>
           <a:chExt cx="12192000" cy="6858000"/>
         </a:xfrm>
       </p:grpSpPr>
@@ -299,8 +299,8 @@
       <p:grpSpPr>
         <a:xfrm>
           <a:off x="0" y="0"/>
+          <a:ext cx="12192000" cy="6858000"/>
           <a:chOff x="0" y="0"/>
-          <a:ext cx="12192000" cy="6858000"/>
           <a:chExt cx="12192000" cy="6858000"/>
         </a:xfrm>
       </p:grpSpPr>
@@ -453,11 +453,25 @@
           <a:schemeClr val="phClr"/>
         </a:solidFill>
         <a:gradFill>
-          <a:gsLst/>
+          <a:gsLst>
+            <a:gs pos="0">
+              <a:schemeClr val="phClr"/>
+            </a:gs>
+            <a:gs pos="100000">
+              <a:schemeClr val="phClr"/>
+            </a:gs>
+          </a:gsLst>
           <a:lin ang="0" scaled="0"/>
         </a:gradFill>
         <a:gradFill>
-          <a:gsLst/>
+          <a:gsLst>
+            <a:gs pos="0">
+              <a:schemeClr val="phClr"/>
+            </a:gs>
+            <a:gs pos="100000">
+              <a:schemeClr val="phClr"/>
+            </a:gs>
+          </a:gsLst>
           <a:lin ang="0" scaled="0"/>
         </a:gradFill>
       </a:fillStyleLst>

</xml_diff>

<commit_message>
feat(docx): add template packs and reference import
</commit_message>
<xml_diff>
--- a/plugin/tests/fixtures/html-native.expected.pptx
+++ b/plugin/tests/fixtures/html-native.expected.pptx
@@ -1,12 +1,12 @@
 
 <file path=ppt/presentation.xml><?xml version="1.0" encoding="utf-8"?>
-<p:presentation xmlns:p="http://schemas.openxmlformats.org/presentationml/2006/main" xmlns:r14="http://schemas.openxmlformats.org/officeDocument/2006/relationships" saveSubsetFonts="1">
+<p:presentation xmlns:p="http://schemas.openxmlformats.org/presentationml/2006/main" xmlns:r="http://schemas.openxmlformats.org/officeDocument/2006/relationships" saveSubsetFonts="1">
   <p:sldMasterIdLst>
-    <p:sldMasterId id="2147483648" r14:id="rIdMaster"/>
+    <p:sldMasterId id="2147483648" r:id="rIdMaster"/>
   </p:sldMasterIdLst>
   <p:sldIdLst>
-    <p:sldId id="256" r14:id="rIdSlide1"/>
-    <p:sldId id="257" r14:id="rIdSlide2"/>
+    <p:sldId id="256" r:id="rIdSlide1"/>
+    <p:sldId id="257" r:id="rIdSlide2"/>
   </p:sldIdLst>
   <p:sldSz cx="12192000" cy="6858000" type="screen16x9"/>
   <p:notesSz cx="6858000" cy="9144000"/>
@@ -39,7 +39,7 @@
 </file>
 
 <file path=ppt/slideMasters/slideMaster1.xml><?xml version="1.0" encoding="utf-8"?>
-<p:sldMaster xmlns:a="http://schemas.openxmlformats.org/drawingml/2006/main" xmlns:p="http://schemas.openxmlformats.org/presentationml/2006/main" xmlns:r14="http://schemas.openxmlformats.org/officeDocument/2006/relationships">
+<p:sldMaster xmlns:a="http://schemas.openxmlformats.org/drawingml/2006/main" xmlns:p="http://schemas.openxmlformats.org/presentationml/2006/main" xmlns:r="http://schemas.openxmlformats.org/officeDocument/2006/relationships">
   <p:cSld>
     <p:bg>
       <p:bgPr>
@@ -67,7 +67,7 @@
   </p:cSld>
   <p:clrMap bg1="lt1" tx1="dk1" bg2="lt2" tx2="dk2" accent1="accent1" accent2="accent2" accent3="accent3" accent4="accent4" accent5="accent5" accent6="accent6" hlink="hlink" folHlink="folHlink"/>
   <p:sldLayoutIdLst>
-    <p:sldLayoutId id="2147483649" r14:id="rIdLayout1"/>
+    <p:sldLayoutId id="2147483649" r:id="rIdLayout1"/>
   </p:sldLayoutIdLst>
   <p:txStyles>
     <p:titleStyle>
@@ -105,7 +105,7 @@
 </file>
 
 <file path=ppt/slides/slide1.xml><?xml version="1.0" encoding="utf-8"?>
-<p:sld xmlns:a="http://schemas.openxmlformats.org/drawingml/2006/main" xmlns:p="http://schemas.openxmlformats.org/presentationml/2006/main" xmlns:r14="http://schemas.openxmlformats.org/officeDocument/2006/relationships">
+<p:sld xmlns:a="http://schemas.openxmlformats.org/drawingml/2006/main" xmlns:p="http://schemas.openxmlformats.org/presentationml/2006/main" xmlns:r="http://schemas.openxmlformats.org/officeDocument/2006/relationships">
   <p:cSld>
     <p:bg>
       <p:bgPr>
@@ -245,7 +245,7 @@
           <p:nvPr/>
         </p:nvPicPr>
         <p:blipFill>
-          <a:blip r14:embed="rIdImage1">
+          <a:blip r:embed="rIdImage1">
             <a:alphaModFix amt="50000"/>
           </a:blip>
           <a:stretch>

</xml_diff>